<commit_message>
Add collision, update ppt with what we have accomplished
</commit_message>
<xml_diff>
--- a/final-presentation.pptx
+++ b/final-presentation.pptx
@@ -12076,479 +12076,30 @@
           <a:chExt cx="0" cy="0"/>
         </a:xfrm>
       </p:grpSpPr>
-      <p:sp>
-        <p:nvSpPr>
-          <p:cNvPr id="103" name="Google Shape;103;p15"/>
-          <p:cNvSpPr txBox="1"/>
-          <p:nvPr/>
-        </p:nvSpPr>
-        <p:spPr>
-          <a:xfrm>
-            <a:off x="1333500" y="2785020"/>
-            <a:ext cx="10096500" cy="548640"/>
-          </a:xfrm>
-          <a:prstGeom prst="rect">
-            <a:avLst/>
-          </a:prstGeom>
-          <a:noFill/>
-          <a:ln>
-            <a:noFill/>
-          </a:ln>
-        </p:spPr>
-        <p:txBody>
-          <a:bodyPr spcFirstLastPara="1" wrap="square" lIns="0" tIns="0" rIns="0" bIns="0" anchor="t" anchorCtr="0">
-            <a:spAutoFit/>
-          </a:bodyPr>
-          <a:lstStyle/>
-          <a:p>
-            <a:pPr marL="0" marR="0" lvl="0" indent="0" algn="l" rtl="0">
-              <a:lnSpc>
-                <a:spcPct val="140000"/>
-              </a:lnSpc>
-              <a:spcBef>
-                <a:spcPts val="0"/>
-              </a:spcBef>
-              <a:spcAft>
-                <a:spcPts val="0"/>
-              </a:spcAft>
-              <a:buNone/>
-            </a:pPr>
-            <a:r>
-              <a:rPr lang="en-US" sz="2550" b="1" i="0" u="none" strike="noStrike" cap="none">
-                <a:solidFill>
-                  <a:srgbClr val="DAFFDE"/>
-                </a:solidFill>
-                <a:latin typeface="Urbanist"/>
-                <a:ea typeface="Urbanist"/>
-                <a:cs typeface="Urbanist"/>
-                <a:sym typeface="Urbanist"/>
-              </a:rPr>
-              <a:t>Graphics:</a:t>
-            </a:r>
-            <a:r>
-              <a:rPr lang="en-US" sz="2550" b="0" i="0" u="none" strike="noStrike" cap="none">
-                <a:solidFill>
-                  <a:srgbClr val="DAFFDE"/>
-                </a:solidFill>
-                <a:latin typeface="Urbanist"/>
-                <a:ea typeface="Urbanist"/>
-                <a:cs typeface="Urbanist"/>
-                <a:sym typeface="Urbanist"/>
-              </a:rPr>
-              <a:t> Fully modeled 3D classroom.</a:t>
-            </a:r>
-            <a:endParaRPr lang="en-US" sz="2550" b="0" i="0" u="none" strike="noStrike" cap="none">
-              <a:solidFill>
-                <a:srgbClr val="DAFFDE"/>
-              </a:solidFill>
-              <a:latin typeface="Urbanist"/>
-              <a:ea typeface="Urbanist"/>
-              <a:cs typeface="Urbanist"/>
-              <a:sym typeface="Urbanist"/>
-            </a:endParaRPr>
-          </a:p>
-        </p:txBody>
-      </p:sp>
-      <p:sp>
-        <p:nvSpPr>
-          <p:cNvPr id="104" name="Google Shape;104;p15"/>
-          <p:cNvSpPr txBox="1"/>
-          <p:nvPr/>
-        </p:nvSpPr>
-        <p:spPr>
-          <a:xfrm>
-            <a:off x="1333500" y="3579286"/>
-            <a:ext cx="10096500" cy="453330"/>
-          </a:xfrm>
-          <a:prstGeom prst="rect">
-            <a:avLst/>
-          </a:prstGeom>
-          <a:noFill/>
-          <a:ln>
-            <a:noFill/>
-          </a:ln>
-        </p:spPr>
-        <p:txBody>
-          <a:bodyPr spcFirstLastPara="1" wrap="square" lIns="0" tIns="0" rIns="0" bIns="0" anchor="t" anchorCtr="0">
-            <a:spAutoFit/>
-          </a:bodyPr>
-          <a:lstStyle/>
-          <a:p>
-            <a:pPr marL="0" marR="0" lvl="0" indent="0" algn="l" rtl="0">
-              <a:lnSpc>
-                <a:spcPct val="140000"/>
-              </a:lnSpc>
-              <a:spcBef>
-                <a:spcPts val="0"/>
-              </a:spcBef>
-              <a:spcAft>
-                <a:spcPts val="0"/>
-              </a:spcAft>
-              <a:buNone/>
-            </a:pPr>
-            <a:r>
-              <a:rPr lang="en-US" sz="2550" b="1" i="0" u="none" strike="noStrike" cap="none">
-                <a:solidFill>
-                  <a:srgbClr val="DAFFDE"/>
-                </a:solidFill>
-                <a:latin typeface="Urbanist"/>
-                <a:ea typeface="Urbanist"/>
-                <a:cs typeface="Urbanist"/>
-                <a:sym typeface="Urbanist"/>
-              </a:rPr>
-              <a:t>Animation:</a:t>
-            </a:r>
-            <a:r>
-              <a:rPr lang="en-US" sz="2550" b="0" i="0" u="none" strike="noStrike" cap="none">
-                <a:solidFill>
-                  <a:srgbClr val="DAFFDE"/>
-                </a:solidFill>
-                <a:latin typeface="Urbanist"/>
-                <a:ea typeface="Urbanist"/>
-                <a:cs typeface="Urbanist"/>
-                <a:sym typeface="Urbanist"/>
-              </a:rPr>
-              <a:t> Character kinematics and dynamic camera movement.</a:t>
-            </a:r>
-            <a:endParaRPr lang="en-US" sz="2550" b="0" i="0" u="none" strike="noStrike" cap="none">
-              <a:solidFill>
-                <a:srgbClr val="DAFFDE"/>
-              </a:solidFill>
-              <a:latin typeface="Urbanist"/>
-              <a:ea typeface="Urbanist"/>
-              <a:cs typeface="Urbanist"/>
-              <a:sym typeface="Urbanist"/>
-            </a:endParaRPr>
-          </a:p>
-        </p:txBody>
-      </p:sp>
-      <p:sp>
-        <p:nvSpPr>
-          <p:cNvPr id="105" name="Google Shape;105;p15"/>
-          <p:cNvSpPr txBox="1"/>
-          <p:nvPr/>
-        </p:nvSpPr>
-        <p:spPr>
-          <a:xfrm>
-            <a:off x="1333500" y="4278362"/>
-            <a:ext cx="10096500" cy="453330"/>
-          </a:xfrm>
-          <a:prstGeom prst="rect">
-            <a:avLst/>
-          </a:prstGeom>
-          <a:noFill/>
-          <a:ln>
-            <a:noFill/>
-          </a:ln>
-        </p:spPr>
-        <p:txBody>
-          <a:bodyPr spcFirstLastPara="1" wrap="square" lIns="0" tIns="0" rIns="0" bIns="0" anchor="t" anchorCtr="0">
-            <a:spAutoFit/>
-          </a:bodyPr>
-          <a:lstStyle/>
-          <a:p>
-            <a:pPr marL="0" marR="0" lvl="0" indent="0" algn="l" rtl="0">
-              <a:lnSpc>
-                <a:spcPct val="140000"/>
-              </a:lnSpc>
-              <a:spcBef>
-                <a:spcPts val="0"/>
-              </a:spcBef>
-              <a:spcAft>
-                <a:spcPts val="0"/>
-              </a:spcAft>
-              <a:buNone/>
-            </a:pPr>
-            <a:r>
-              <a:rPr lang="en-US" sz="2550" b="1" i="0" u="none" strike="noStrike" cap="none">
-                <a:solidFill>
-                  <a:srgbClr val="DAFFDE"/>
-                </a:solidFill>
-                <a:latin typeface="Urbanist"/>
-                <a:ea typeface="Urbanist"/>
-                <a:cs typeface="Urbanist"/>
-                <a:sym typeface="Urbanist"/>
-              </a:rPr>
-              <a:t>Dynamics:</a:t>
-            </a:r>
-            <a:r>
-              <a:rPr lang="en-US" sz="2550" b="0" i="0" u="none" strike="noStrike" cap="none">
-                <a:solidFill>
-                  <a:srgbClr val="DAFFDE"/>
-                </a:solidFill>
-                <a:latin typeface="Urbanist"/>
-                <a:ea typeface="Urbanist"/>
-                <a:cs typeface="Urbanist"/>
-                <a:sym typeface="Urbanist"/>
-              </a:rPr>
-              <a:t> Real-time student pressure flames and AC wind simulation.</a:t>
-            </a:r>
-            <a:endParaRPr lang="en-US" sz="2550" b="0" i="0" u="none" strike="noStrike" cap="none">
-              <a:solidFill>
-                <a:srgbClr val="DAFFDE"/>
-              </a:solidFill>
-              <a:latin typeface="Urbanist"/>
-              <a:ea typeface="Urbanist"/>
-              <a:cs typeface="Urbanist"/>
-              <a:sym typeface="Urbanist"/>
-            </a:endParaRPr>
-          </a:p>
-        </p:txBody>
-      </p:sp>
-      <p:sp>
-        <p:nvSpPr>
-          <p:cNvPr id="106" name="Google Shape;106;p15"/>
-          <p:cNvSpPr txBox="1"/>
-          <p:nvPr/>
-        </p:nvSpPr>
-        <p:spPr>
-          <a:xfrm>
-            <a:off x="1333500" y="5455592"/>
-            <a:ext cx="10096500" cy="453330"/>
-          </a:xfrm>
-          <a:prstGeom prst="rect">
-            <a:avLst/>
-          </a:prstGeom>
-          <a:noFill/>
-          <a:ln>
-            <a:noFill/>
-          </a:ln>
-        </p:spPr>
-        <p:txBody>
-          <a:bodyPr spcFirstLastPara="1" wrap="square" lIns="0" tIns="0" rIns="0" bIns="0" anchor="t" anchorCtr="0">
-            <a:spAutoFit/>
-          </a:bodyPr>
-          <a:lstStyle/>
-          <a:p>
-            <a:pPr marL="0" marR="0" lvl="0" indent="0" algn="l" rtl="0">
-              <a:lnSpc>
-                <a:spcPct val="140000"/>
-              </a:lnSpc>
-              <a:spcBef>
-                <a:spcPts val="0"/>
-              </a:spcBef>
-              <a:spcAft>
-                <a:spcPts val="0"/>
-              </a:spcAft>
-              <a:buNone/>
-            </a:pPr>
-            <a:r>
-              <a:rPr lang="en-US" sz="2550" b="1" i="0" u="none" strike="noStrike" cap="none">
-                <a:solidFill>
-                  <a:srgbClr val="DAFFDE"/>
-                </a:solidFill>
-                <a:latin typeface="Urbanist"/>
-                <a:ea typeface="Urbanist"/>
-                <a:cs typeface="Urbanist"/>
-                <a:sym typeface="Urbanist"/>
-              </a:rPr>
-              <a:t>UI:</a:t>
-            </a:r>
-            <a:r>
-              <a:rPr lang="en-US" sz="2550" b="0" i="0" u="none" strike="noStrike" cap="none">
-                <a:solidFill>
-                  <a:srgbClr val="DAFFDE"/>
-                </a:solidFill>
-                <a:latin typeface="Urbanist"/>
-                <a:ea typeface="Urbanist"/>
-                <a:cs typeface="Urbanist"/>
-                <a:sym typeface="Urbanist"/>
-              </a:rPr>
-              <a:t> Full 3D whiteboard interaction system with legacy HUD parity.</a:t>
-            </a:r>
-            <a:endParaRPr lang="en-US" sz="2550" b="0" i="0" u="none" strike="noStrike" cap="none">
-              <a:solidFill>
-                <a:srgbClr val="DAFFDE"/>
-              </a:solidFill>
-              <a:latin typeface="Urbanist"/>
-              <a:ea typeface="Urbanist"/>
-              <a:cs typeface="Urbanist"/>
-              <a:sym typeface="Urbanist"/>
-            </a:endParaRPr>
-          </a:p>
-        </p:txBody>
-      </p:sp>
       <p:pic>
         <p:nvPicPr>
-          <p:cNvPr id="107" name="Google Shape;107;p15" descr="image.png"/>
-          <p:cNvPicPr preferRelativeResize="0"/>
+          <p:cNvPr id="3" name="Picture 2"/>
+          <p:cNvPicPr>
+            <a:picLocks noChangeAspect="1"/>
+          </p:cNvPicPr>
           <p:nvPr/>
         </p:nvPicPr>
-        <p:blipFill rotWithShape="1">
+        <p:blipFill>
           <a:blip r:embed="rId1"/>
-          <a:srcRect/>
           <a:stretch>
             <a:fillRect/>
           </a:stretch>
         </p:blipFill>
         <p:spPr>
           <a:xfrm>
-            <a:off x="762000" y="2870745"/>
-            <a:ext cx="361950" cy="381000"/>
+            <a:off x="0" y="-4445"/>
+            <a:ext cx="12192000" cy="6867525"/>
           </a:xfrm>
           <a:prstGeom prst="rect">
             <a:avLst/>
           </a:prstGeom>
-          <a:noFill/>
-          <a:ln>
-            <a:noFill/>
-          </a:ln>
         </p:spPr>
       </p:pic>
-      <p:pic>
-        <p:nvPicPr>
-          <p:cNvPr id="108" name="Google Shape;108;p15" descr="image.png"/>
-          <p:cNvPicPr preferRelativeResize="0"/>
-          <p:nvPr/>
-        </p:nvPicPr>
-        <p:blipFill rotWithShape="1">
-          <a:blip r:embed="rId2"/>
-          <a:srcRect/>
-          <a:stretch>
-            <a:fillRect/>
-          </a:stretch>
-        </p:blipFill>
-        <p:spPr>
-          <a:xfrm>
-            <a:off x="762000" y="3665011"/>
-            <a:ext cx="228600" cy="381000"/>
-          </a:xfrm>
-          <a:prstGeom prst="rect">
-            <a:avLst/>
-          </a:prstGeom>
-          <a:noFill/>
-          <a:ln>
-            <a:noFill/>
-          </a:ln>
-        </p:spPr>
-      </p:pic>
-      <p:pic>
-        <p:nvPicPr>
-          <p:cNvPr id="109" name="Google Shape;109;p15" descr="image.png"/>
-          <p:cNvPicPr preferRelativeResize="0"/>
-          <p:nvPr/>
-        </p:nvPicPr>
-        <p:blipFill rotWithShape="1">
-          <a:blip r:embed="rId3"/>
-          <a:srcRect/>
-          <a:stretch>
-            <a:fillRect/>
-          </a:stretch>
-        </p:blipFill>
-        <p:spPr>
-          <a:xfrm>
-            <a:off x="762000" y="4364087"/>
-            <a:ext cx="314325" cy="381000"/>
-          </a:xfrm>
-          <a:prstGeom prst="rect">
-            <a:avLst/>
-          </a:prstGeom>
-          <a:noFill/>
-          <a:ln>
-            <a:noFill/>
-          </a:ln>
-        </p:spPr>
-      </p:pic>
-      <p:pic>
-        <p:nvPicPr>
-          <p:cNvPr id="110" name="Google Shape;110;p15" descr="image.png"/>
-          <p:cNvPicPr preferRelativeResize="0"/>
-          <p:nvPr/>
-        </p:nvPicPr>
-        <p:blipFill rotWithShape="1">
-          <a:blip r:embed="rId4"/>
-          <a:srcRect/>
-          <a:stretch>
-            <a:fillRect/>
-          </a:stretch>
-        </p:blipFill>
-        <p:spPr>
-          <a:xfrm>
-            <a:off x="762000" y="5541317"/>
-            <a:ext cx="409575" cy="381000"/>
-          </a:xfrm>
-          <a:prstGeom prst="rect">
-            <a:avLst/>
-          </a:prstGeom>
-          <a:noFill/>
-          <a:ln>
-            <a:noFill/>
-          </a:ln>
-        </p:spPr>
-      </p:pic>
-      <p:sp>
-        <p:nvSpPr>
-          <p:cNvPr id="111" name="Google Shape;111;p15"/>
-          <p:cNvSpPr txBox="1"/>
-          <p:nvPr/>
-        </p:nvSpPr>
-        <p:spPr>
-          <a:xfrm>
-            <a:off x="762000" y="1394370"/>
-            <a:ext cx="11201400" cy="762000"/>
-          </a:xfrm>
-          <a:prstGeom prst="rect">
-            <a:avLst/>
-          </a:prstGeom>
-          <a:noFill/>
-          <a:ln>
-            <a:noFill/>
-          </a:ln>
-        </p:spPr>
-        <p:txBody>
-          <a:bodyPr spcFirstLastPara="1" wrap="square" lIns="0" tIns="0" rIns="0" bIns="0" anchor="t" anchorCtr="0">
-            <a:spAutoFit/>
-          </a:bodyPr>
-          <a:lstStyle/>
-          <a:p>
-            <a:pPr marL="0" marR="0" lvl="0" indent="0" algn="l" rtl="0">
-              <a:lnSpc>
-                <a:spcPct val="100000"/>
-              </a:lnSpc>
-              <a:spcBef>
-                <a:spcPts val="0"/>
-              </a:spcBef>
-              <a:spcAft>
-                <a:spcPts val="0"/>
-              </a:spcAft>
-              <a:buNone/>
-            </a:pPr>
-            <a:r>
-              <a:rPr lang="en-US" sz="6000" b="1" i="0" u="none" strike="noStrike" cap="none">
-                <a:solidFill>
-                  <a:srgbClr val="F5F5F5"/>
-                </a:solidFill>
-                <a:latin typeface="Urbanist"/>
-                <a:ea typeface="Urbanist"/>
-                <a:cs typeface="Urbanist"/>
-                <a:sym typeface="Urbanist"/>
-              </a:rPr>
-              <a:t>What have we </a:t>
-            </a:r>
-            <a:r>
-              <a:rPr lang="en-US" sz="6000" b="1" i="0" u="none" strike="noStrike" cap="none">
-                <a:solidFill>
-                  <a:srgbClr val="DEFF9A"/>
-                </a:solidFill>
-                <a:latin typeface="Urbanist"/>
-                <a:ea typeface="Urbanist"/>
-                <a:cs typeface="Urbanist"/>
-                <a:sym typeface="Urbanist"/>
-              </a:rPr>
-              <a:t>accomplished?</a:t>
-            </a:r>
-            <a:endParaRPr lang="en-US" sz="6000" b="1" i="0" u="none" strike="noStrike" cap="none">
-              <a:solidFill>
-                <a:srgbClr val="DEFF9A"/>
-              </a:solidFill>
-              <a:latin typeface="Urbanist"/>
-              <a:ea typeface="Urbanist"/>
-              <a:cs typeface="Urbanist"/>
-              <a:sym typeface="Urbanist"/>
-            </a:endParaRPr>
-          </a:p>
-        </p:txBody>
-      </p:sp>
     </p:spTree>
   </p:cSld>
   <p:clrMapOvr>
@@ -12698,7 +12249,7 @@
         </p:nvSpPr>
         <p:spPr>
           <a:xfrm>
-            <a:off x="762000" y="2956470"/>
+            <a:off x="762000" y="3202215"/>
             <a:ext cx="10668000" cy="453330"/>
           </a:xfrm>
           <a:prstGeom prst="rect">
@@ -12771,183 +12322,6 @@
               <a:ea typeface="Urbanist"/>
               <a:cs typeface="Urbanist"/>
               <a:sym typeface="Urbanist"/>
-            </a:endParaRPr>
-          </a:p>
-        </p:txBody>
-      </p:sp>
-      <p:sp>
-        <p:nvSpPr>
-          <p:cNvPr id="121" name="Google Shape;121;p16"/>
-          <p:cNvSpPr/>
-          <p:nvPr/>
-        </p:nvSpPr>
-        <p:spPr>
-          <a:xfrm>
-            <a:off x="762000" y="5914876"/>
-            <a:ext cx="10668000" cy="1143000"/>
-          </a:xfrm>
-          <a:prstGeom prst="rect">
-            <a:avLst/>
-          </a:prstGeom>
-          <a:solidFill>
-            <a:srgbClr val="000000"/>
-          </a:solidFill>
-          <a:ln>
-            <a:noFill/>
-          </a:ln>
-        </p:spPr>
-        <p:txBody>
-          <a:bodyPr spcFirstLastPara="1" wrap="square" lIns="91425" tIns="45700" rIns="91425" bIns="45700" anchor="ctr" anchorCtr="0">
-            <a:noAutofit/>
-          </a:bodyPr>
-          <a:lstStyle/>
-          <a:p>
-            <a:pPr marL="0" marR="0" lvl="0" indent="0" algn="ctr" rtl="0">
-              <a:spcBef>
-                <a:spcPts val="0"/>
-              </a:spcBef>
-              <a:spcAft>
-                <a:spcPts val="0"/>
-              </a:spcAft>
-              <a:buNone/>
-            </a:pPr>
-            <a:endParaRPr sz="1800" b="0" i="0" u="none" strike="noStrike" cap="none">
-              <a:solidFill>
-                <a:schemeClr val="dk1"/>
-              </a:solidFill>
-              <a:latin typeface="Calibri"/>
-              <a:ea typeface="Calibri"/>
-              <a:cs typeface="Calibri"/>
-              <a:sym typeface="Calibri"/>
-            </a:endParaRPr>
-          </a:p>
-        </p:txBody>
-      </p:sp>
-      <p:sp>
-        <p:nvSpPr>
-          <p:cNvPr id="122" name="Google Shape;122;p16"/>
-          <p:cNvSpPr txBox="1"/>
-          <p:nvPr/>
-        </p:nvSpPr>
-        <p:spPr>
-          <a:xfrm>
-            <a:off x="1047750" y="6200626"/>
-            <a:ext cx="10096500" cy="571500"/>
-          </a:xfrm>
-          <a:prstGeom prst="rect">
-            <a:avLst/>
-          </a:prstGeom>
-          <a:noFill/>
-          <a:ln>
-            <a:noFill/>
-          </a:ln>
-        </p:spPr>
-        <p:txBody>
-          <a:bodyPr spcFirstLastPara="1" wrap="square" lIns="0" tIns="0" rIns="0" bIns="0" anchor="t" anchorCtr="0">
-            <a:spAutoFit/>
-          </a:bodyPr>
-          <a:lstStyle/>
-          <a:p>
-            <a:pPr marL="0" marR="0" lvl="0" indent="0" algn="l" rtl="0">
-              <a:spcBef>
-                <a:spcPts val="0"/>
-              </a:spcBef>
-              <a:spcAft>
-                <a:spcPts val="0"/>
-              </a:spcAft>
-              <a:buNone/>
-            </a:pPr>
-            <a:r>
-              <a:rPr lang="en-US" sz="1650" b="0" i="0" u="none" strike="noStrike" cap="none">
-                <a:solidFill>
-                  <a:srgbClr val="DAFFDE"/>
-                </a:solidFill>
-                <a:latin typeface="Arial"/>
-                <a:ea typeface="Arial"/>
-                <a:cs typeface="Arial"/>
-                <a:sym typeface="Arial"/>
-              </a:rPr>
-              <a:t>const elementUnderPointer = document.elementFromPoint(clientX, clientY);</a:t>
-            </a:r>
-            <a:br>
-              <a:rPr lang="en-US" sz="1800" b="0" i="0" u="none" strike="noStrike" cap="none">
-                <a:solidFill>
-                  <a:schemeClr val="dk1"/>
-                </a:solidFill>
-                <a:latin typeface="Calibri"/>
-                <a:ea typeface="Calibri"/>
-                <a:cs typeface="Calibri"/>
-                <a:sym typeface="Calibri"/>
-              </a:rPr>
-            </a:br>
-            <a:r>
-              <a:rPr lang="en-US" sz="1650" b="0" i="0" u="none" strike="noStrike" cap="none">
-                <a:solidFill>
-                  <a:srgbClr val="DAFFDE"/>
-                </a:solidFill>
-                <a:latin typeface="Arial"/>
-                <a:ea typeface="Arial"/>
-                <a:cs typeface="Arial"/>
-                <a:sym typeface="Arial"/>
-              </a:rPr>
-              <a:t> elementUnderPointer.dispatchEvent(new MouseEvent("click", { ... }));</a:t>
-            </a:r>
-            <a:endParaRPr lang="en-US" sz="1650" b="0" i="0" u="none" strike="noStrike" cap="none">
-              <a:solidFill>
-                <a:srgbClr val="DAFFDE"/>
-              </a:solidFill>
-              <a:latin typeface="Arial"/>
-              <a:ea typeface="Arial"/>
-              <a:cs typeface="Arial"/>
-              <a:sym typeface="Arial"/>
-            </a:endParaRPr>
-          </a:p>
-        </p:txBody>
-      </p:sp>
-      <p:sp>
-        <p:nvSpPr>
-          <p:cNvPr id="123" name="Google Shape;123;p16"/>
-          <p:cNvSpPr/>
-          <p:nvPr/>
-        </p:nvSpPr>
-        <p:spPr>
-          <a:xfrm>
-            <a:off x="762000" y="5914876"/>
-            <a:ext cx="76200" cy="1143000"/>
-          </a:xfrm>
-          <a:prstGeom prst="rect">
-            <a:avLst/>
-          </a:prstGeom>
-          <a:solidFill>
-            <a:srgbClr val="DEFF9A"/>
-          </a:solidFill>
-          <a:ln>
-            <a:noFill/>
-          </a:ln>
-        </p:spPr>
-        <p:txBody>
-          <a:bodyPr spcFirstLastPara="1" wrap="square" lIns="91425" tIns="45700" rIns="91425" bIns="45700" anchor="ctr" anchorCtr="0">
-            <a:noAutofit/>
-          </a:bodyPr>
-          <a:lstStyle/>
-          <a:p>
-            <a:pPr marL="0" marR="0" lvl="0" indent="0" algn="ctr" rtl="0">
-              <a:spcBef>
-                <a:spcPts val="0"/>
-              </a:spcBef>
-              <a:spcAft>
-                <a:spcPts val="0"/>
-              </a:spcAft>
-              <a:buNone/>
-            </a:pPr>
-            <a:endParaRPr sz="1800" b="0" i="0" u="none" strike="noStrike" cap="none">
-              <a:solidFill>
-                <a:schemeClr val="dk1"/>
-              </a:solidFill>
-              <a:latin typeface="Calibri"/>
-              <a:ea typeface="Calibri"/>
-              <a:cs typeface="Calibri"/>
-              <a:sym typeface="Calibri"/>
             </a:endParaRPr>
           </a:p>
         </p:txBody>

</xml_diff>